<commit_message>
Final submission: Metro Ethernet MPLS Project - Full 5 Chapters Report
</commit_message>
<xml_diff>
--- a/baocao/thuyet_minh_do_an.pptx
+++ b/baocao/thuyet_minh_do_an.pptx
@@ -13,6 +13,7 @@
     <p:sldId id="261" r:id="rId12"/>
     <p:sldId id="262" r:id="rId13"/>
     <p:sldId id="263" r:id="rId14"/>
+    <p:sldId id="264" r:id="rId15"/>
   </p:sldIdLst>
   <p:sldSz cx="9144000" cy="6858000" type="screen4x3"/>
   <p:notesSz cx="6858000" cy="9144000"/>
@@ -3142,7 +3143,7 @@
           </a:p>
           <a:p>
             <a:r>
-              <a:t>GVHD: ThS. Lê Viết Thanh</a:t>
+              <a:t>Ngành: Mạng máy tính và truyền thông dữ liệu</a:t>
             </a:r>
           </a:p>
         </p:txBody>
@@ -3181,7 +3182,7 @@
           <a:lstStyle/>
           <a:p>
             <a:r>
-              <a:t>1. Cấu trúc thư mục &amp; Tổ chức mã nguồn</a:t>
+              <a:t>1. Mục tiêu và Phạm vi nghiên cứu</a:t>
             </a:r>
           </a:p>
         </p:txBody>
@@ -3202,32 +3203,22 @@
           <a:lstStyle/>
           <a:p>
             <a:r>
-              <a:t>- tkm_cuoi_ky_52300267/</a:t>
-            </a:r>
-          </a:p>
-          <a:p>
-            <a:r>
-              <a:t>  + configs/: Chứa các file cấu hình mẫu (Templates) cho FRR (OSPF, LDP).</a:t>
-            </a:r>
-          </a:p>
-          <a:p>
-            <a:r>
-              <a:t>  + scripts/: Các công cụ tự động hóa (Vẽ sơ đồ, Đo hiệu năng).</a:t>
-            </a:r>
-          </a:p>
-          <a:p>
-            <a:r>
-              <a:t>  + baocao/: Toàn bộ mã nguồn LaTeX của bài báo cáo.</a:t>
-            </a:r>
-          </a:p>
-          <a:p>
-            <a:r>
-              <a:t>  + main_topology.py: File logic chính để xây dựng mạng trên Mininet.</a:t>
-            </a:r>
-          </a:p>
-          <a:p>
-            <a:r>
-              <a:t>- Lý do chọn: Kiến trúc Modular, tách biệt giữa Logic mạng và Cấu hình dịch vụ.</a:t>
+              <a:t>- Xây dựng mô hình Metro Ethernet MAN kết nối đa chi nhánh.</a:t>
+            </a:r>
+          </a:p>
+          <a:p>
+            <a:r>
+              <a:t>- Triển khai kỹ thuật chuyển mạch nhãn MPLS (Multiprotocol Label Switching).</a:t>
+            </a:r>
+          </a:p>
+          <a:p>
+            <a:r>
+              <a:t>- So sánh hiệu năng giữa 3 kiến trúc LAN: Flat, 3-Tier và Leaf-Spine.</a:t>
+            </a:r>
+          </a:p>
+          <a:p>
+            <a:r>
+              <a:t>- Đánh giá khả năng mở rộng và tính bảo mật của mạng lõi ISP.</a:t>
             </a:r>
           </a:p>
         </p:txBody>
@@ -3266,7 +3257,7 @@
           <a:lstStyle/>
           <a:p>
             <a:r>
-              <a:t>2. Sơ đồ mạng &amp; Kiến trúc hệ thống</a:t>
+              <a:t>2. Thiết kế Topology hệ thống</a:t>
             </a:r>
           </a:p>
         </p:txBody>
@@ -3281,42 +3272,65 @@
             <p:ph idx="1"/>
           </p:nvPr>
         </p:nvSpPr>
-        <p:spPr/>
-        <p:txBody>
-          <a:bodyPr/>
-          <a:lstStyle/>
-          <a:p>
-            <a:r>
-              <a:t>- MPLS Backbone: Gồm 2 Router lõi (P) và 2 Router biên (PE).</a:t>
-            </a:r>
-          </a:p>
-          <a:p>
-            <a:r>
-              <a:t>- 3 Chi nhánh (Sites) với 3 kiến trúc LAN đặc thù:</a:t>
-            </a:r>
-          </a:p>
-          <a:p>
-            <a:r>
-              <a:t>  + Site A: Flat Network (Đơn giản).</a:t>
-            </a:r>
-          </a:p>
-          <a:p>
-            <a:r>
-              <a:t>  + Site B: 3-Tier Architecture (Core-Dist-Access).</a:t>
-            </a:r>
-          </a:p>
-          <a:p>
-            <a:r>
-              <a:t>  + Site C: Leaf-Spine Architecture (Hiện đại, tối ưu cho Data Center).</a:t>
-            </a:r>
-          </a:p>
-          <a:p>
-            <a:r>
-              <a:t>- Kết nối: Các chi nhánh kết nối về ISP qua đường truyền WAN 100Mbps.</a:t>
-            </a:r>
-          </a:p>
-        </p:txBody>
-      </p:sp>
+        <p:spPr>
+          <a:xfrm>
+            <a:ext cx="4114800" cy="0"/>
+          </a:xfrm>
+        </p:spPr>
+        <p:txBody>
+          <a:bodyPr/>
+          <a:lstStyle/>
+          <a:p>
+            <a:r>
+              <a:t>- ISP Core: Router P1, P2 chạy OSPF/LDP.</a:t>
+            </a:r>
+          </a:p>
+          <a:p>
+            <a:r>
+              <a:t>- ISP Edge: Router PE1, PE2 kết nối khách hàng.</a:t>
+            </a:r>
+          </a:p>
+          <a:p>
+            <a:r>
+              <a:t>- Site A: Flat Network (Mô hình doanh nghiệp nhỏ).</a:t>
+            </a:r>
+          </a:p>
+          <a:p>
+            <a:r>
+              <a:t>- Site B: Core-Dist-Access (Mô hình tiêu chuẩn).</a:t>
+            </a:r>
+          </a:p>
+          <a:p>
+            <a:r>
+              <a:t>- Site C: Leaf-Spine (Mô hình Data Center).</a:t>
+            </a:r>
+          </a:p>
+        </p:txBody>
+      </p:sp>
+      <p:pic>
+        <p:nvPicPr>
+          <p:cNvPr id="4" name="Picture 3" descr="network_detailed_topology.png"/>
+          <p:cNvPicPr>
+            <a:picLocks noChangeAspect="1"/>
+          </p:cNvPicPr>
+          <p:nvPr/>
+        </p:nvPicPr>
+        <p:blipFill>
+          <a:blip r:embed="rId2"/>
+          <a:stretch>
+            <a:fillRect/>
+          </a:stretch>
+        </p:blipFill>
+        <p:spPr>
+          <a:xfrm>
+            <a:off x="4389120" y="1371600"/>
+            <a:ext cx="4389120" cy="2785788"/>
+          </a:xfrm>
+          <a:prstGeom prst="rect">
+            <a:avLst/>
+          </a:prstGeom>
+        </p:spPr>
+      </p:pic>
     </p:spTree>
   </p:cSld>
   <p:clrMapOvr>
@@ -3351,7 +3365,7 @@
           <a:lstStyle/>
           <a:p>
             <a:r>
-              <a:t>3. Vai trò các thiết bị trong hệ thống</a:t>
+              <a:t>3. Hiện thực hóa trên Mininet</a:t>
             </a:r>
           </a:p>
         </p:txBody>
@@ -3366,33 +3380,60 @@
             <p:ph idx="1"/>
           </p:nvPr>
         </p:nvSpPr>
-        <p:spPr/>
-        <p:txBody>
-          <a:bodyPr/>
-          <a:lstStyle/>
-          <a:p>
-            <a:r>
-              <a:t>- Router P (Provider): Chuyển mạch nhãn tốc độ cao trong mạng lõi.</a:t>
-            </a:r>
-          </a:p>
-          <a:p>
-            <a:r>
-              <a:t>- Router PE (Provider Edge): Gán/Gỡ nhãn (Push/Pop) khi dữ liệu vào/ra mạng lõi.</a:t>
-            </a:r>
-          </a:p>
-          <a:p>
-            <a:r>
-              <a:t>- Router CE (Customer Edge): Định tuyến tĩnh, làm Gateway cho mạng LAN.</a:t>
-            </a:r>
-          </a:p>
-          <a:p>
-            <a:r>
-              <a:t>- Switches: OVS Switches giả lập L2, Site C bật STP để chống Loop.</a:t>
-            </a:r>
-          </a:p>
-          <a:p>
-            <a:r>
-              <a:t>- Hosts: Các máy trạm giả lập luồng dữ liệu (Ping, iPerf).</a:t>
+        <p:spPr>
+          <a:xfrm>
+            <a:ext cx="4114800" cy="0"/>
+          </a:xfrm>
+        </p:spPr>
+        <p:txBody>
+          <a:bodyPr/>
+          <a:lstStyle/>
+          <a:p>
+            <a:r>
+              <a:t>- Sử dụng LinuxRouter và OVS Switches.</a:t>
+            </a:r>
+          </a:p>
+          <a:p>
+            <a:r>
+              <a:t>- Cấu hình STP cho Site C để chống Loop lớp 2.</a:t>
+            </a:r>
+          </a:p>
+          <a:p>
+            <a:r>
+              <a:t>- Quy hoạch IP khoa học: /30 cho Backbone, /24 cho LAN.</a:t>
+            </a:r>
+          </a:p>
+          <a:p>
+            <a:r>
+              <a:t>- Kiểm tra Nodes/Net: Đầy đủ 11 Switch, 7 Router và 10 Hosts.</a:t>
+            </a:r>
+          </a:p>
+        </p:txBody>
+      </p:sp>
+      <p:sp>
+        <p:nvSpPr>
+          <p:cNvPr id="4" name="TextBox 3"/>
+          <p:cNvSpPr txBox="1"/>
+          <p:nvPr/>
+        </p:nvSpPr>
+        <p:spPr>
+          <a:xfrm>
+            <a:off x="5029200" y="2743200"/>
+            <a:ext cx="2743200" cy="914400"/>
+          </a:xfrm>
+          <a:prstGeom prst="rect">
+            <a:avLst/>
+          </a:prstGeom>
+          <a:noFill/>
+        </p:spPr>
+        <p:txBody>
+          <a:bodyPr wrap="none">
+            <a:spAutoFit/>
+          </a:bodyPr>
+          <a:lstStyle/>
+          <a:p>
+            <a:r>
+              <a:t>[Thieu anh: mininet_nodes_net.png]</a:t>
             </a:r>
           </a:p>
         </p:txBody>
@@ -3431,7 +3472,7 @@
           <a:lstStyle/>
           <a:p>
             <a:r>
-              <a:t>4. Cách thức cấu hình hệ thống</a:t>
+              <a:t>4. Minh chứng Hội tụ định tuyến</a:t>
             </a:r>
           </a:p>
         </p:txBody>
@@ -3446,28 +3487,60 @@
             <p:ph idx="1"/>
           </p:nvPr>
         </p:nvSpPr>
-        <p:spPr/>
-        <p:txBody>
-          <a:bodyPr/>
-          <a:lstStyle/>
-          <a:p>
-            <a:r>
-              <a:t>- Mạng lõi (P/PE): Chạy OSPF Area 0 để thông tuyến IP và LDP để trao đổi nhãn.</a:t>
-            </a:r>
-          </a:p>
-          <a:p>
-            <a:r>
-              <a:t>- Kết nối CE-PE: Sử dụng Định tuyến tĩnh (Static Route) trỏ về Default Gateway.</a:t>
-            </a:r>
-          </a:p>
-          <a:p>
-            <a:r>
-              <a:t>- Tự động hóa: Sử dụng Python để sinh file cấu hình FRR động từ Templates.</a:t>
-            </a:r>
-          </a:p>
-          <a:p>
-            <a:r>
-              <a:t>- Cơ chế Redistribution: PE quảng bá các đường mạng LAN của khách hàng vào OSPF thông qua lệnh 'redistribute kernel'.</a:t>
+        <p:spPr>
+          <a:xfrm>
+            <a:ext cx="4114800" cy="0"/>
+          </a:xfrm>
+        </p:spPr>
+        <p:txBody>
+          <a:bodyPr/>
+          <a:lstStyle/>
+          <a:p>
+            <a:r>
+              <a:t>- OSPF đạt trạng thái FULL giữa P và PE.</a:t>
+            </a:r>
+          </a:p>
+          <a:p>
+            <a:r>
+              <a:t>- LDP phát nhãn tự động cho các dải Loopback và LAN.</a:t>
+            </a:r>
+          </a:p>
+          <a:p>
+            <a:r>
+              <a:t>- Bảng định tuyến xuất hiện 'Label' (24, 25, implicit-null).</a:t>
+            </a:r>
+          </a:p>
+          <a:p>
+            <a:r>
+              <a:t>- Chứng minh dữ liệu đi qua hầm MPLS thay vì IP thuần.</a:t>
+            </a:r>
+          </a:p>
+        </p:txBody>
+      </p:sp>
+      <p:sp>
+        <p:nvSpPr>
+          <p:cNvPr id="4" name="TextBox 3"/>
+          <p:cNvSpPr txBox="1"/>
+          <p:nvPr/>
+        </p:nvSpPr>
+        <p:spPr>
+          <a:xfrm>
+            <a:off x="5029200" y="2743200"/>
+            <a:ext cx="2743200" cy="914400"/>
+          </a:xfrm>
+          <a:prstGeom prst="rect">
+            <a:avLst/>
+          </a:prstGeom>
+          <a:noFill/>
+        </p:spPr>
+        <p:txBody>
+          <a:bodyPr wrap="none">
+            <a:spAutoFit/>
+          </a:bodyPr>
+          <a:lstStyle/>
+          <a:p>
+            <a:r>
+              <a:t>[Thieu anh: ospf_neighbor.png]</a:t>
             </a:r>
           </a:p>
         </p:txBody>
@@ -3506,7 +3579,7 @@
           <a:lstStyle/>
           <a:p>
             <a:r>
-              <a:t>5. Kết quả kiểm tra &amp; Ý nghĩa</a:t>
+              <a:t>5. Kiểm tra kết nối &amp; Tính ẩn danh</a:t>
             </a:r>
           </a:p>
         </p:txBody>
@@ -3521,23 +3594,55 @@
             <p:ph idx="1"/>
           </p:nvPr>
         </p:nvSpPr>
-        <p:spPr/>
-        <p:txBody>
-          <a:bodyPr/>
-          <a:lstStyle/>
-          <a:p>
-            <a:r>
-              <a:t>- Lệnh Ping: Đạt 0% Packet Loss giữa tất cả các Site (A, B, C).</a:t>
-            </a:r>
-          </a:p>
-          <a:p>
-            <a:r>
-              <a:t>- Lệnh Traceroute: Hiển thị sự hiện diện của nhãn MPLS tại các hop mạng lõi.</a:t>
-            </a:r>
-          </a:p>
-          <a:p>
-            <a:r>
-              <a:t>- Ý nghĩa: Chứng minh gói tin không đi theo định tuyến IP truyền thống mà đang được chuyển mạch nhãn nhanh chóng và an toàn.</a:t>
+        <p:spPr>
+          <a:xfrm>
+            <a:ext cx="4114800" cy="0"/>
+          </a:xfrm>
+        </p:spPr>
+        <p:txBody>
+          <a:bodyPr/>
+          <a:lstStyle/>
+          <a:p>
+            <a:r>
+              <a:t>- Ping xuyên chi nhánh: Đạt 0% Loss, RTT ổn định.</a:t>
+            </a:r>
+          </a:p>
+          <a:p>
+            <a:r>
+              <a:t>- Traceroute: Xuất hiện dấu * * * tại các hop mạng lõi.</a:t>
+            </a:r>
+          </a:p>
+          <a:p>
+            <a:r>
+              <a:t>- Giải thích: Tính năng ẩn IP của MPLS giúp bảo mật hạ tầng ISP.</a:t>
+            </a:r>
+          </a:p>
+        </p:txBody>
+      </p:sp>
+      <p:sp>
+        <p:nvSpPr>
+          <p:cNvPr id="4" name="TextBox 3"/>
+          <p:cNvSpPr txBox="1"/>
+          <p:nvPr/>
+        </p:nvSpPr>
+        <p:spPr>
+          <a:xfrm>
+            <a:off x="5029200" y="2743200"/>
+            <a:ext cx="2743200" cy="914400"/>
+          </a:xfrm>
+          <a:prstGeom prst="rect">
+            <a:avLst/>
+          </a:prstGeom>
+          <a:noFill/>
+        </p:spPr>
+        <p:txBody>
+          <a:bodyPr wrap="none">
+            <a:spAutoFit/>
+          </a:bodyPr>
+          <a:lstStyle/>
+          <a:p>
+            <a:r>
+              <a:t>[Thieu anh: traceroute_mpls.png]</a:t>
             </a:r>
           </a:p>
         </p:txBody>
@@ -3576,7 +3681,7 @@
           <a:lstStyle/>
           <a:p>
             <a:r>
-              <a:t>6. Phân tích kết quả đo lường</a:t>
+              <a:t>6. Đánh giá Thông lượng (Throughput)</a:t>
             </a:r>
           </a:p>
         </p:txBody>
@@ -3591,32 +3696,55 @@
             <p:ph idx="1"/>
           </p:nvPr>
         </p:nvSpPr>
-        <p:spPr/>
-        <p:txBody>
-          <a:bodyPr/>
-          <a:lstStyle/>
-          <a:p>
-            <a:r>
-              <a:t>- Thông lượng (Throughput): Đạt ~100Mbps (xuyên Backbone) và ~190Mbps (nội bộ PE).</a:t>
-            </a:r>
-          </a:p>
-          <a:p>
-            <a:r>
-              <a:t>- Độ trễ (Delay): Ổn định ở mức ~26ms cho các chi nhánh cách xa nhau.</a:t>
-            </a:r>
-          </a:p>
-          <a:p>
-            <a:r>
-              <a:t>- So sánh: Leaf-Spine cho thấy băng thông ổn định nhất khi tải nặng.</a:t>
-            </a:r>
-          </a:p>
-          <a:p>
-            <a:r>
-              <a:t>- MPLS giúp giảm tải xử lý cho các Router lõi bằng cách gỡ nhãn tại chặng áp chót (PHP).</a:t>
-            </a:r>
-          </a:p>
-        </p:txBody>
-      </p:sp>
+        <p:spPr>
+          <a:xfrm>
+            <a:ext cx="4114800" cy="0"/>
+          </a:xfrm>
+        </p:spPr>
+        <p:txBody>
+          <a:bodyPr/>
+          <a:lstStyle/>
+          <a:p>
+            <a:r>
+              <a:t>- Site B -&gt; Site C (Nội bộ PE): Đạt băng thông cao nhất (~189Mbps).</a:t>
+            </a:r>
+          </a:p>
+          <a:p>
+            <a:r>
+              <a:t>- Site A -&gt; Site B (Xuyên lõi): Bị giới hạn bởi nút thắt WAN (~100Mbps).</a:t>
+            </a:r>
+          </a:p>
+          <a:p>
+            <a:r>
+              <a:t>- Leaf-Spine thể hiện sự ổn định vượt trội khi có lưu lượng cao.</a:t>
+            </a:r>
+          </a:p>
+        </p:txBody>
+      </p:sp>
+      <p:pic>
+        <p:nvPicPr>
+          <p:cNvPr id="4" name="Picture 3" descr="chart_throughput.png"/>
+          <p:cNvPicPr>
+            <a:picLocks noChangeAspect="1"/>
+          </p:cNvPicPr>
+          <p:nvPr/>
+        </p:nvPicPr>
+        <p:blipFill>
+          <a:blip r:embed="rId2"/>
+          <a:stretch>
+            <a:fillRect/>
+          </a:stretch>
+        </p:blipFill>
+        <p:spPr>
+          <a:xfrm>
+            <a:off x="4389120" y="1371600"/>
+            <a:ext cx="4389120" cy="2633472"/>
+          </a:xfrm>
+          <a:prstGeom prst="rect">
+            <a:avLst/>
+          </a:prstGeom>
+        </p:spPr>
+      </p:pic>
     </p:spTree>
   </p:cSld>
   <p:clrMapOvr>
@@ -3651,7 +3779,7 @@
           <a:lstStyle/>
           <a:p>
             <a:r>
-              <a:t>7. Kết luận</a:t>
+              <a:t>7. Phân tích Độ trễ (RTT)</a:t>
             </a:r>
           </a:p>
         </p:txBody>
@@ -3666,28 +3794,126 @@
             <p:ph idx="1"/>
           </p:nvPr>
         </p:nvSpPr>
-        <p:spPr/>
-        <p:txBody>
-          <a:bodyPr/>
-          <a:lstStyle/>
-          <a:p>
-            <a:r>
-              <a:t>- Đồ án đã triển khai thành công mô hình Metro Ethernet MPLS thực tế.</a:t>
-            </a:r>
-          </a:p>
-          <a:p>
-            <a:r>
-              <a:t>- Giải quyết được bài toán kết nối đa chi nhánh có kiến trúc LAN khác biệt.</a:t>
-            </a:r>
-          </a:p>
-          <a:p>
-            <a:r>
-              <a:t>- Hệ thống hoạt động ổn định, hiệu năng cao và đáp ứng đủ các tiêu chuẩn kỹ thuật.</a:t>
-            </a:r>
-          </a:p>
-          <a:p>
-            <a:r>
-              <a:t>- Nắm vững kỹ năng sử dụng Mininet, FRRouting và các công cụ đo lường mạng.</a:t>
+        <p:spPr>
+          <a:xfrm>
+            <a:ext cx="4114800" cy="0"/>
+          </a:xfrm>
+        </p:spPr>
+        <p:txBody>
+          <a:bodyPr/>
+          <a:lstStyle/>
+          <a:p>
+            <a:r>
+              <a:t>- Độ trễ trung bình duy trì mức 20ms - 27ms.</a:t>
+            </a:r>
+          </a:p>
+          <a:p>
+            <a:r>
+              <a:t>- MPLS giúp giảm Overhead xử lý tại Core Router.</a:t>
+            </a:r>
+          </a:p>
+          <a:p>
+            <a:r>
+              <a:t>- Kiến trúc LAN phân tầng giúp tăng tính sẵn sàng (Availability).</a:t>
+            </a:r>
+          </a:p>
+        </p:txBody>
+      </p:sp>
+      <p:pic>
+        <p:nvPicPr>
+          <p:cNvPr id="4" name="Picture 3" descr="chart_delay.png"/>
+          <p:cNvPicPr>
+            <a:picLocks noChangeAspect="1"/>
+          </p:cNvPicPr>
+          <p:nvPr/>
+        </p:nvPicPr>
+        <p:blipFill>
+          <a:blip r:embed="rId2"/>
+          <a:stretch>
+            <a:fillRect/>
+          </a:stretch>
+        </p:blipFill>
+        <p:spPr>
+          <a:xfrm>
+            <a:off x="4389120" y="1371600"/>
+            <a:ext cx="4389120" cy="2633472"/>
+          </a:xfrm>
+          <a:prstGeom prst="rect">
+            <a:avLst/>
+          </a:prstGeom>
+        </p:spPr>
+      </p:pic>
+    </p:spTree>
+  </p:cSld>
+  <p:clrMapOvr>
+    <a:masterClrMapping/>
+  </p:clrMapOvr>
+</p:sld>
+</file>
+
+<file path=ppt/slides/slide9.xml><?xml version="1.0" encoding="utf-8"?>
+<p:sld xmlns:a="http://schemas.openxmlformats.org/drawingml/2006/main" xmlns:p="http://schemas.openxmlformats.org/presentationml/2006/main" xmlns:r="http://schemas.openxmlformats.org/officeDocument/2006/relationships">
+  <p:cSld>
+    <p:spTree>
+      <p:nvGrpSpPr>
+        <p:cNvPr id="1" name=""/>
+        <p:cNvGrpSpPr/>
+        <p:nvPr/>
+      </p:nvGrpSpPr>
+      <p:grpSpPr/>
+      <p:sp>
+        <p:nvSpPr>
+          <p:cNvPr id="2" name="Title 1"/>
+          <p:cNvSpPr>
+            <a:spLocks noGrp="1"/>
+          </p:cNvSpPr>
+          <p:nvPr>
+            <p:ph type="title"/>
+          </p:nvPr>
+        </p:nvSpPr>
+        <p:spPr/>
+        <p:txBody>
+          <a:bodyPr/>
+          <a:lstStyle/>
+          <a:p>
+            <a:r>
+              <a:t>8. Tổng kết đồ án</a:t>
+            </a:r>
+          </a:p>
+        </p:txBody>
+      </p:sp>
+      <p:sp>
+        <p:nvSpPr>
+          <p:cNvPr id="3" name="Content Placeholder 2"/>
+          <p:cNvSpPr>
+            <a:spLocks noGrp="1"/>
+          </p:cNvSpPr>
+          <p:nvPr>
+            <p:ph idx="1"/>
+          </p:nvPr>
+        </p:nvSpPr>
+        <p:spPr/>
+        <p:txBody>
+          <a:bodyPr/>
+          <a:lstStyle/>
+          <a:p>
+            <a:r>
+              <a:t>- Hoàn thành 100% mục tiêu thiết kế và triển khai.</a:t>
+            </a:r>
+          </a:p>
+          <a:p>
+            <a:r>
+              <a:t>- Hệ thống tự động hóa hoàn toàn từ cấu hình đến đo lường.</a:t>
+            </a:r>
+          </a:p>
+          <a:p>
+            <a:r>
+              <a:t>- Nắm vững công nghệ chuyển mạch nhãn hiện đại nhất hiện nay.</a:t>
+            </a:r>
+          </a:p>
+          <a:p>
+            <a:r>
+              <a:t>- Hướng phát triển: Triển khai QoS và Traffic Engineering trên MPLS.</a:t>
             </a:r>
           </a:p>
         </p:txBody>

</xml_diff>